<commit_message>
Correct the deck and notebook notes to match the results
The deck, its speaker notes and the notebook reflection said the default 0.5 cutoff gave near-zero recall, that threshold tuning mattered more than the model, that all four models used class weights, that the booster had the smallest cross-validation spread and that Type H was about 6% of the data. The saved outputs show validation recall of 0.588 at 0.5 and 0.608 at the tuned 0.496, a booster PR-AUC of 0.759 against 0.594 for the decision tree, no class weights on the booster, the decision tree with the smallest spread (0.019) and 118 of 1,501 validation machines in Type H. The deck is rebuilt from build_deck.py with those numbers, the HTML export is regenerated, and the README drops an untimed runtime claim.
</commit_message>
<xml_diff>
--- a/presentation/AAI201 Capstone Predictive Maintenance Drew Menning.pptx
+++ b/presentation/AAI201 Capstone Predictive Maintenance Drew Menning.pptx
@@ -648,7 +648,7 @@
           <a:lstStyle/>
           <a:p>
             <a:r>
-              <a:t>I built up from simple to complex. Logistic regression and a depth-limited decision tree gave me a floor. Then Random Forest and HistGradientBoosting as the ensembles. All four use balanced class weights to address the 3.4 percent failure rate. The boosting model uses validation-based early stopping, which addresses my proposal feedback about avoiding leakage in early stopping. I deliberately did not use SMOTE; the dataset is already synthetic, so synthesizing minority samples on top would just compound the same modeling assumptions twice. For the failure decision threshold I chose the value that maximizes F1 on the validation set, then applied it unchanged to the test set. And I checked fairness across the three product quality grades.</a:t>
+              <a:t>I built up from simple to complex. Logistic regression and a depth-limited decision tree gave me a floor. Then Random Forest and HistGradientBoosting as the ensembles. The first three use balanced class weights to address the 3.4 percent failure rate; the booster has none and relies on the tuned threshold. The boosting model uses validation-based early stopping, which addresses my proposal feedback about avoiding leakage in early stopping. I deliberately did not use SMOTE; the dataset is already synthetic, so synthesizing minority samples on top would just compound the same modeling assumptions twice. For the failure decision threshold I chose the value that maximizes F1 on the validation set, then applied it unchanged to the test set. And I checked fairness across the three product quality grades.</a:t>
             </a:r>
           </a:p>
         </p:txBody>
@@ -718,7 +718,7 @@
           <a:lstStyle/>
           <a:p>
             <a:r>
-              <a:t>Five-fold cross-validation on PR-AUC. Logistic regression and decision tree are the baselines, and you can see ensembles pull ahead. HistGradientBoosting wins, with mean PR-AUC of 0.759 and the smallest standard deviation, 0.026, so it's not a lucky split. I'm using PR-AUC instead of ROC-AUC because at 3.4 percent positive rate, ROC-AUC stays high almost by default. PR-AUC is the metric that actually penalizes a model for missing failures.</a:t>
+              <a:t>Five-fold cross-validation on PR-AUC. Logistic regression and decision tree are the baselines, and you can see ensembles pull ahead. HistGradientBoosting wins with a mean PR-AUC of 0.759 and a standard deviation of 0.026, well ahead of Random Forest at 0.675. I'm using PR-AUC instead of ROC-AUC because at 3.4 percent positive rate, ROC-AUC stays high almost by default. PR-AUC is the metric that actually penalizes a model for missing failures.</a:t>
             </a:r>
           </a:p>
         </p:txBody>
@@ -928,7 +928,7 @@
           <a:lstStyle/>
           <a:p>
             <a:r>
-              <a:t>The biggest thing I learned is that imbalanced classification is mostly about thresholds and metrics, not about the model family. The decision tree at PR-AUC 0.59 was not far behind the tuned booster at 0.76, and the difference between a useless and a useful model came from threshold choice, not model choice. The hardest decision was picking the failure threshold; default 0.5 produced near-zero recall, so I used the F1-max threshold from validation. Honest limitation: this is a synthetic dataset, so the result is credible on AI4I but not a deployment guarantee. Next steps in priority order: validate on a real predictive-maintenance dataset like NASA C-MAPSS, replace F1 with a cost-based threshold, fix the Type H blind spot, and add drift monitoring. Thanks for watching, the GitHub link is on this slide.</a:t>
+              <a:t>The biggest thing I learned is that the model family mattered more than I expected. In cross-validation the booster reached a PR-AUC of 0.76 against 0.59 for the decision tree, while threshold tuning barely moved the cutoff, from 0.5 to 0.496, and lifted validation recall from 0.588 to 0.608. The hardest decision was picking the failure threshold without a real cost ratio, so I used the F1-max threshold from validation. Honest limitation: this is a synthetic dataset, so the result is credible on AI4I but not a deployment guarantee. Next steps in priority order: validate on a real predictive-maintenance dataset like NASA C-MAPSS, replace F1 with a cost-based threshold, fix the Type H blind spot, and add drift monitoring. Thanks for watching, the GitHub link is on this slide.</a:t>
             </a:r>
           </a:p>
         </p:txBody>
@@ -6839,7 +6839,7 @@
                 </a:solidFill>
                 <a:latin typeface="Cambria"/>
               </a:rPr>
-              <a:t>HGB wins on mean and variance.</a:t>
+              <a:t>HGB has the best mean.</a:t>
             </a:r>
           </a:p>
         </p:txBody>
@@ -6878,7 +6878,7 @@
                 </a:solidFill>
                 <a:latin typeface="Calibri"/>
               </a:rPr>
-              <a:t>0.759 mean PR-AUC with the smallest spread (±0.026), so the choice is stable across folds, not lucky.</a:t>
+              <a:t>0.759 mean PR-AUC (±0.026), well ahead of Random Forest at 0.675.</a:t>
             </a:r>
           </a:p>
         </p:txBody>
@@ -10027,7 +10027,7 @@
                 </a:solidFill>
                 <a:latin typeface="Calibri"/>
               </a:rPr>
-              <a:t>H is the smallest grade in the dataset (only ~6%). With four real failures in validation, the model has almost nothing to learn from. The result generalizes: any deployment plan would need stratified sampling, a separate H-specific model, or an explicit out-of-scope flag for that grade.</a:t>
+              <a:t>H is the smallest grade: 118 of the 1,501 validation machines. With four real failures in validation, the model has almost nothing to learn from. The result generalizes: any deployment plan would need stratified sampling, a separate H-specific model, or an explicit out-of-scope flag for that grade.</a:t>
             </a:r>
           </a:p>
         </p:txBody>
@@ -10333,7 +10333,7 @@
                 </a:solidFill>
                 <a:latin typeface="Calibri"/>
               </a:rPr>
-              <a:t>Threshold tuning and the right metric beat picking a fancier model. Decision Tree with PR-AUC 0.59 was not far behind a tuned booster at 0.76. Class imbalance is less about the model and more about how predictions are turned into decisions.</a:t>
+              <a:t>The model mattered more than the threshold. In cross-validation the booster's PR-AUC was 0.76 against 0.59 for the decision tree, and tuning only moved the cutoff from 0.5 to 0.496. PR-AUC split the models far more clearly than ROC-AUC.</a:t>
             </a:r>
           </a:p>
         </p:txBody>
@@ -10499,7 +10499,7 @@
                 </a:solidFill>
                 <a:latin typeface="Calibri"/>
               </a:rPr>
-              <a:t>Choosing the failure threshold. Default 0.5 produced near-zero recall on imbalanced data. F1-max on validation gave a defensible threshold (0.496) without needing a cost ratio I couldn't justify on synthetic data.</a:t>
+              <a:t>Choosing the failure threshold. F1-max on validation picked 0.496, close to the default 0.5, and lifted validation recall from 0.588 to 0.608 without needing a cost ratio I couldn't justify on synthetic data.</a:t>
             </a:r>
           </a:p>
         </p:txBody>

</xml_diff>